<commit_message>
Remove top-right timer from PowerPoint presentation slides
</commit_message>
<xml_diff>
--- a/AmanKumar_Capstone_Presentation.pptx
+++ b/AmanKumar_Capstone_Presentation.pptx
@@ -3456,7 +3456,7 @@
         <p:spPr>
           <a:xfrm>
             <a:off x="731520" y="457200"/>
-            <a:ext cx="8686800" cy="731520"/>
+            <a:ext cx="10698480" cy="731520"/>
           </a:xfrm>
           <a:prstGeom prst="rect">
             <a:avLst/>
@@ -3484,42 +3484,7 @@
       </p:sp>
       <p:sp>
         <p:nvSpPr>
-          <p:cNvPr id="3" name="TextBox 2"/>
-          <p:cNvSpPr txBox="1"/>
-          <p:nvPr/>
-        </p:nvSpPr>
-        <p:spPr>
-          <a:xfrm>
-            <a:off x="9601200" y="457200"/>
-            <a:ext cx="1828800" cy="457200"/>
-          </a:xfrm>
-          <a:prstGeom prst="rect">
-            <a:avLst/>
-          </a:prstGeom>
-          <a:noFill/>
-        </p:spPr>
-        <p:txBody>
-          <a:bodyPr wrap="none">
-            <a:spAutoFit/>
-          </a:bodyPr>
-          <a:lstStyle/>
-          <a:p>
-            <a:pPr algn="r">
-              <a:defRPr sz="1200" b="1">
-                <a:solidFill>
-                  <a:srgbClr val="10B981"/>
-                </a:solidFill>
-              </a:defRPr>
-            </a:pPr>
-            <a:r>
-              <a:t>⏱ 16:30 - 20:00</a:t>
-            </a:r>
-          </a:p>
-        </p:txBody>
-      </p:sp>
-      <p:sp>
-        <p:nvSpPr>
-          <p:cNvPr id="4" name="Rounded Rectangle 3"/>
+          <p:cNvPr id="3" name="Rounded Rectangle 2"/>
           <p:cNvSpPr/>
           <p:nvPr/>
         </p:nvSpPr>
@@ -3666,7 +3631,7 @@
         <p:spPr>
           <a:xfrm>
             <a:off x="731520" y="457200"/>
-            <a:ext cx="8686800" cy="731520"/>
+            <a:ext cx="10698480" cy="731520"/>
           </a:xfrm>
           <a:prstGeom prst="rect">
             <a:avLst/>
@@ -3694,42 +3659,7 @@
       </p:sp>
       <p:sp>
         <p:nvSpPr>
-          <p:cNvPr id="3" name="TextBox 2"/>
-          <p:cNvSpPr txBox="1"/>
-          <p:nvPr/>
-        </p:nvSpPr>
-        <p:spPr>
-          <a:xfrm>
-            <a:off x="9601200" y="457200"/>
-            <a:ext cx="1828800" cy="457200"/>
-          </a:xfrm>
-          <a:prstGeom prst="rect">
-            <a:avLst/>
-          </a:prstGeom>
-          <a:noFill/>
-        </p:spPr>
-        <p:txBody>
-          <a:bodyPr wrap="none">
-            <a:spAutoFit/>
-          </a:bodyPr>
-          <a:lstStyle/>
-          <a:p>
-            <a:pPr algn="r">
-              <a:defRPr sz="1200" b="1">
-                <a:solidFill>
-                  <a:srgbClr val="10B981"/>
-                </a:solidFill>
-              </a:defRPr>
-            </a:pPr>
-            <a:r>
-              <a:t>⏱ 1:00 - 2:30</a:t>
-            </a:r>
-          </a:p>
-        </p:txBody>
-      </p:sp>
-      <p:sp>
-        <p:nvSpPr>
-          <p:cNvPr id="4" name="Rounded Rectangle 3"/>
+          <p:cNvPr id="3" name="Rounded Rectangle 2"/>
           <p:cNvSpPr/>
           <p:nvPr/>
         </p:nvSpPr>
@@ -3795,7 +3725,7 @@
       </p:sp>
       <p:sp>
         <p:nvSpPr>
-          <p:cNvPr id="5" name="Rounded Rectangle 4"/>
+          <p:cNvPr id="4" name="Rounded Rectangle 3"/>
           <p:cNvSpPr/>
           <p:nvPr/>
         </p:nvSpPr>
@@ -3861,7 +3791,7 @@
       </p:sp>
       <p:sp>
         <p:nvSpPr>
-          <p:cNvPr id="6" name="Rounded Rectangle 5"/>
+          <p:cNvPr id="5" name="Rounded Rectangle 4"/>
           <p:cNvSpPr/>
           <p:nvPr/>
         </p:nvSpPr>
@@ -3927,7 +3857,7 @@
       </p:sp>
       <p:sp>
         <p:nvSpPr>
-          <p:cNvPr id="7" name="Rounded Rectangle 6"/>
+          <p:cNvPr id="6" name="Rounded Rectangle 5"/>
           <p:cNvSpPr/>
           <p:nvPr/>
         </p:nvSpPr>
@@ -4026,7 +3956,7 @@
         <p:spPr>
           <a:xfrm>
             <a:off x="731520" y="457200"/>
-            <a:ext cx="8686800" cy="731520"/>
+            <a:ext cx="10698480" cy="731520"/>
           </a:xfrm>
           <a:prstGeom prst="rect">
             <a:avLst/>
@@ -4052,44 +3982,9 @@
           </a:p>
         </p:txBody>
       </p:sp>
-      <p:sp>
-        <p:nvSpPr>
-          <p:cNvPr id="3" name="TextBox 2"/>
-          <p:cNvSpPr txBox="1"/>
-          <p:nvPr/>
-        </p:nvSpPr>
-        <p:spPr>
-          <a:xfrm>
-            <a:off x="9601200" y="457200"/>
-            <a:ext cx="1828800" cy="457200"/>
-          </a:xfrm>
-          <a:prstGeom prst="rect">
-            <a:avLst/>
-          </a:prstGeom>
-          <a:noFill/>
-        </p:spPr>
-        <p:txBody>
-          <a:bodyPr wrap="none">
-            <a:spAutoFit/>
-          </a:bodyPr>
-          <a:lstStyle/>
-          <a:p>
-            <a:pPr algn="r">
-              <a:defRPr sz="1200" b="1">
-                <a:solidFill>
-                  <a:srgbClr val="10B981"/>
-                </a:solidFill>
-              </a:defRPr>
-            </a:pPr>
-            <a:r>
-              <a:t>⏱ 2:30 - 4:30</a:t>
-            </a:r>
-          </a:p>
-        </p:txBody>
-      </p:sp>
       <p:pic>
         <p:nvPicPr>
-          <p:cNvPr id="4" name="Picture 3" descr="system_flow_diagram_1789758333259.jpg"/>
+          <p:cNvPr id="3" name="Picture 2" descr="system_flow_diagram_1789758333259.jpg"/>
           <p:cNvPicPr>
             <a:picLocks noChangeAspect="1"/>
           </p:cNvPicPr>
@@ -4146,7 +4041,7 @@
         <p:spPr>
           <a:xfrm>
             <a:off x="731520" y="457200"/>
-            <a:ext cx="8686800" cy="731520"/>
+            <a:ext cx="10698480" cy="731520"/>
           </a:xfrm>
           <a:prstGeom prst="rect">
             <a:avLst/>
@@ -4174,42 +4069,7 @@
       </p:sp>
       <p:sp>
         <p:nvSpPr>
-          <p:cNvPr id="3" name="TextBox 2"/>
-          <p:cNvSpPr txBox="1"/>
-          <p:nvPr/>
-        </p:nvSpPr>
-        <p:spPr>
-          <a:xfrm>
-            <a:off x="9601200" y="457200"/>
-            <a:ext cx="1828800" cy="457200"/>
-          </a:xfrm>
-          <a:prstGeom prst="rect">
-            <a:avLst/>
-          </a:prstGeom>
-          <a:noFill/>
-        </p:spPr>
-        <p:txBody>
-          <a:bodyPr wrap="none">
-            <a:spAutoFit/>
-          </a:bodyPr>
-          <a:lstStyle/>
-          <a:p>
-            <a:pPr algn="r">
-              <a:defRPr sz="1200" b="1">
-                <a:solidFill>
-                  <a:srgbClr val="10B981"/>
-                </a:solidFill>
-              </a:defRPr>
-            </a:pPr>
-            <a:r>
-              <a:t>⏱ 4:30 - 6:30</a:t>
-            </a:r>
-          </a:p>
-        </p:txBody>
-      </p:sp>
-      <p:sp>
-        <p:nvSpPr>
-          <p:cNvPr id="4" name="Rounded Rectangle 3"/>
+          <p:cNvPr id="3" name="Rounded Rectangle 2"/>
           <p:cNvSpPr/>
           <p:nvPr/>
         </p:nvSpPr>
@@ -4283,7 +4143,7 @@
       </p:sp>
       <p:sp>
         <p:nvSpPr>
-          <p:cNvPr id="5" name="Rounded Rectangle 4"/>
+          <p:cNvPr id="4" name="Rounded Rectangle 3"/>
           <p:cNvSpPr/>
           <p:nvPr/>
         </p:nvSpPr>
@@ -4357,7 +4217,7 @@
       </p:sp>
       <p:sp>
         <p:nvSpPr>
-          <p:cNvPr id="6" name="Rounded Rectangle 5"/>
+          <p:cNvPr id="5" name="Rounded Rectangle 4"/>
           <p:cNvSpPr/>
           <p:nvPr/>
         </p:nvSpPr>
@@ -4464,7 +4324,7 @@
         <p:spPr>
           <a:xfrm>
             <a:off x="731520" y="457200"/>
-            <a:ext cx="8686800" cy="731520"/>
+            <a:ext cx="10698480" cy="731520"/>
           </a:xfrm>
           <a:prstGeom prst="rect">
             <a:avLst/>
@@ -4492,42 +4352,7 @@
       </p:sp>
       <p:sp>
         <p:nvSpPr>
-          <p:cNvPr id="3" name="TextBox 2"/>
-          <p:cNvSpPr txBox="1"/>
-          <p:nvPr/>
-        </p:nvSpPr>
-        <p:spPr>
-          <a:xfrm>
-            <a:off x="9601200" y="457200"/>
-            <a:ext cx="1828800" cy="457200"/>
-          </a:xfrm>
-          <a:prstGeom prst="rect">
-            <a:avLst/>
-          </a:prstGeom>
-          <a:noFill/>
-        </p:spPr>
-        <p:txBody>
-          <a:bodyPr wrap="none">
-            <a:spAutoFit/>
-          </a:bodyPr>
-          <a:lstStyle/>
-          <a:p>
-            <a:pPr algn="r">
-              <a:defRPr sz="1200" b="1">
-                <a:solidFill>
-                  <a:srgbClr val="10B981"/>
-                </a:solidFill>
-              </a:defRPr>
-            </a:pPr>
-            <a:r>
-              <a:t>⏱ 6:30 - 8:30</a:t>
-            </a:r>
-          </a:p>
-        </p:txBody>
-      </p:sp>
-      <p:sp>
-        <p:nvSpPr>
-          <p:cNvPr id="4" name="Rounded Rectangle 3"/>
+          <p:cNvPr id="3" name="Rounded Rectangle 2"/>
           <p:cNvSpPr/>
           <p:nvPr/>
         </p:nvSpPr>
@@ -4597,7 +4422,7 @@
       </p:sp>
       <p:sp>
         <p:nvSpPr>
-          <p:cNvPr id="5" name="Rounded Rectangle 4"/>
+          <p:cNvPr id="4" name="Rounded Rectangle 3"/>
           <p:cNvSpPr/>
           <p:nvPr/>
         </p:nvSpPr>
@@ -4667,7 +4492,7 @@
       </p:sp>
       <p:sp>
         <p:nvSpPr>
-          <p:cNvPr id="6" name="Rounded Rectangle 5"/>
+          <p:cNvPr id="5" name="Rounded Rectangle 4"/>
           <p:cNvSpPr/>
           <p:nvPr/>
         </p:nvSpPr>
@@ -4770,7 +4595,7 @@
         <p:spPr>
           <a:xfrm>
             <a:off x="731520" y="457200"/>
-            <a:ext cx="8686800" cy="731520"/>
+            <a:ext cx="10698480" cy="731520"/>
           </a:xfrm>
           <a:prstGeom prst="rect">
             <a:avLst/>
@@ -4798,42 +4623,7 @@
       </p:sp>
       <p:sp>
         <p:nvSpPr>
-          <p:cNvPr id="3" name="TextBox 2"/>
-          <p:cNvSpPr txBox="1"/>
-          <p:nvPr/>
-        </p:nvSpPr>
-        <p:spPr>
-          <a:xfrm>
-            <a:off x="9601200" y="457200"/>
-            <a:ext cx="1828800" cy="457200"/>
-          </a:xfrm>
-          <a:prstGeom prst="rect">
-            <a:avLst/>
-          </a:prstGeom>
-          <a:noFill/>
-        </p:spPr>
-        <p:txBody>
-          <a:bodyPr wrap="none">
-            <a:spAutoFit/>
-          </a:bodyPr>
-          <a:lstStyle/>
-          <a:p>
-            <a:pPr algn="r">
-              <a:defRPr sz="1200" b="1">
-                <a:solidFill>
-                  <a:srgbClr val="10B981"/>
-                </a:solidFill>
-              </a:defRPr>
-            </a:pPr>
-            <a:r>
-              <a:t>⏱ 8:30 - 10:30</a:t>
-            </a:r>
-          </a:p>
-        </p:txBody>
-      </p:sp>
-      <p:sp>
-        <p:nvSpPr>
-          <p:cNvPr id="4" name="Rounded Rectangle 3"/>
+          <p:cNvPr id="3" name="Rounded Rectangle 2"/>
           <p:cNvSpPr/>
           <p:nvPr/>
         </p:nvSpPr>
@@ -4903,7 +4693,7 @@
       </p:sp>
       <p:sp>
         <p:nvSpPr>
-          <p:cNvPr id="5" name="Rounded Rectangle 4"/>
+          <p:cNvPr id="4" name="Rounded Rectangle 3"/>
           <p:cNvSpPr/>
           <p:nvPr/>
         </p:nvSpPr>
@@ -4969,7 +4759,7 @@
       </p:sp>
       <p:sp>
         <p:nvSpPr>
-          <p:cNvPr id="6" name="Rounded Rectangle 5"/>
+          <p:cNvPr id="5" name="Rounded Rectangle 4"/>
           <p:cNvSpPr/>
           <p:nvPr/>
         </p:nvSpPr>
@@ -5035,7 +4825,7 @@
       </p:sp>
       <p:sp>
         <p:nvSpPr>
-          <p:cNvPr id="7" name="Rounded Rectangle 6"/>
+          <p:cNvPr id="6" name="Rounded Rectangle 5"/>
           <p:cNvSpPr/>
           <p:nvPr/>
         </p:nvSpPr>
@@ -5134,7 +4924,7 @@
         <p:spPr>
           <a:xfrm>
             <a:off x="731520" y="457200"/>
-            <a:ext cx="8686800" cy="731520"/>
+            <a:ext cx="10698480" cy="731520"/>
           </a:xfrm>
           <a:prstGeom prst="rect">
             <a:avLst/>
@@ -5162,42 +4952,7 @@
       </p:sp>
       <p:sp>
         <p:nvSpPr>
-          <p:cNvPr id="3" name="TextBox 2"/>
-          <p:cNvSpPr txBox="1"/>
-          <p:nvPr/>
-        </p:nvSpPr>
-        <p:spPr>
-          <a:xfrm>
-            <a:off x="9601200" y="457200"/>
-            <a:ext cx="1828800" cy="457200"/>
-          </a:xfrm>
-          <a:prstGeom prst="rect">
-            <a:avLst/>
-          </a:prstGeom>
-          <a:noFill/>
-        </p:spPr>
-        <p:txBody>
-          <a:bodyPr wrap="none">
-            <a:spAutoFit/>
-          </a:bodyPr>
-          <a:lstStyle/>
-          <a:p>
-            <a:pPr algn="r">
-              <a:defRPr sz="1200" b="1">
-                <a:solidFill>
-                  <a:srgbClr val="10B981"/>
-                </a:solidFill>
-              </a:defRPr>
-            </a:pPr>
-            <a:r>
-              <a:t>⏱ 10:30 - 12:30</a:t>
-            </a:r>
-          </a:p>
-        </p:txBody>
-      </p:sp>
-      <p:sp>
-        <p:nvSpPr>
-          <p:cNvPr id="4" name="Rounded Rectangle 3"/>
+          <p:cNvPr id="3" name="Rounded Rectangle 2"/>
           <p:cNvSpPr/>
           <p:nvPr/>
         </p:nvSpPr>
@@ -5263,7 +5018,7 @@
       </p:sp>
       <p:sp>
         <p:nvSpPr>
-          <p:cNvPr id="5" name="Rounded Rectangle 4"/>
+          <p:cNvPr id="4" name="Rounded Rectangle 3"/>
           <p:cNvSpPr/>
           <p:nvPr/>
         </p:nvSpPr>
@@ -5329,7 +5084,7 @@
       </p:sp>
       <p:sp>
         <p:nvSpPr>
-          <p:cNvPr id="6" name="Rounded Rectangle 5"/>
+          <p:cNvPr id="5" name="Rounded Rectangle 4"/>
           <p:cNvSpPr/>
           <p:nvPr/>
         </p:nvSpPr>
@@ -5395,7 +5150,7 @@
       </p:sp>
       <p:sp>
         <p:nvSpPr>
-          <p:cNvPr id="7" name="Rounded Rectangle 6"/>
+          <p:cNvPr id="6" name="Rounded Rectangle 5"/>
           <p:cNvSpPr/>
           <p:nvPr/>
         </p:nvSpPr>
@@ -5494,7 +5249,7 @@
         <p:spPr>
           <a:xfrm>
             <a:off x="731520" y="457200"/>
-            <a:ext cx="8686800" cy="731520"/>
+            <a:ext cx="10698480" cy="731520"/>
           </a:xfrm>
           <a:prstGeom prst="rect">
             <a:avLst/>
@@ -5522,42 +5277,7 @@
       </p:sp>
       <p:sp>
         <p:nvSpPr>
-          <p:cNvPr id="3" name="TextBox 2"/>
-          <p:cNvSpPr txBox="1"/>
-          <p:nvPr/>
-        </p:nvSpPr>
-        <p:spPr>
-          <a:xfrm>
-            <a:off x="9601200" y="457200"/>
-            <a:ext cx="1828800" cy="457200"/>
-          </a:xfrm>
-          <a:prstGeom prst="rect">
-            <a:avLst/>
-          </a:prstGeom>
-          <a:noFill/>
-        </p:spPr>
-        <p:txBody>
-          <a:bodyPr wrap="none">
-            <a:spAutoFit/>
-          </a:bodyPr>
-          <a:lstStyle/>
-          <a:p>
-            <a:pPr algn="r">
-              <a:defRPr sz="1200" b="1">
-                <a:solidFill>
-                  <a:srgbClr val="10B981"/>
-                </a:solidFill>
-              </a:defRPr>
-            </a:pPr>
-            <a:r>
-              <a:t>⏱ 12:30 - 15:00</a:t>
-            </a:r>
-          </a:p>
-        </p:txBody>
-      </p:sp>
-      <p:sp>
-        <p:nvSpPr>
-          <p:cNvPr id="4" name="Rounded Rectangle 3"/>
+          <p:cNvPr id="3" name="Rounded Rectangle 2"/>
           <p:cNvSpPr/>
           <p:nvPr/>
         </p:nvSpPr>
@@ -5623,7 +5343,7 @@
       </p:sp>
       <p:sp>
         <p:nvSpPr>
-          <p:cNvPr id="5" name="Rounded Rectangle 4"/>
+          <p:cNvPr id="4" name="Rounded Rectangle 3"/>
           <p:cNvSpPr/>
           <p:nvPr/>
         </p:nvSpPr>
@@ -5689,7 +5409,7 @@
       </p:sp>
       <p:sp>
         <p:nvSpPr>
-          <p:cNvPr id="6" name="Rounded Rectangle 5"/>
+          <p:cNvPr id="5" name="Rounded Rectangle 4"/>
           <p:cNvSpPr/>
           <p:nvPr/>
         </p:nvSpPr>
@@ -5755,7 +5475,7 @@
       </p:sp>
       <p:sp>
         <p:nvSpPr>
-          <p:cNvPr id="7" name="Rounded Rectangle 6"/>
+          <p:cNvPr id="6" name="Rounded Rectangle 5"/>
           <p:cNvSpPr/>
           <p:nvPr/>
         </p:nvSpPr>
@@ -5854,7 +5574,7 @@
         <p:spPr>
           <a:xfrm>
             <a:off x="731520" y="457200"/>
-            <a:ext cx="8686800" cy="731520"/>
+            <a:ext cx="10698480" cy="731520"/>
           </a:xfrm>
           <a:prstGeom prst="rect">
             <a:avLst/>
@@ -5882,42 +5602,7 @@
       </p:sp>
       <p:sp>
         <p:nvSpPr>
-          <p:cNvPr id="3" name="TextBox 2"/>
-          <p:cNvSpPr txBox="1"/>
-          <p:nvPr/>
-        </p:nvSpPr>
-        <p:spPr>
-          <a:xfrm>
-            <a:off x="9601200" y="457200"/>
-            <a:ext cx="1828800" cy="457200"/>
-          </a:xfrm>
-          <a:prstGeom prst="rect">
-            <a:avLst/>
-          </a:prstGeom>
-          <a:noFill/>
-        </p:spPr>
-        <p:txBody>
-          <a:bodyPr wrap="none">
-            <a:spAutoFit/>
-          </a:bodyPr>
-          <a:lstStyle/>
-          <a:p>
-            <a:pPr algn="r">
-              <a:defRPr sz="1200" b="1">
-                <a:solidFill>
-                  <a:srgbClr val="10B981"/>
-                </a:solidFill>
-              </a:defRPr>
-            </a:pPr>
-            <a:r>
-              <a:t>⏱ 15:00 - 16:30</a:t>
-            </a:r>
-          </a:p>
-        </p:txBody>
-      </p:sp>
-      <p:sp>
-        <p:nvSpPr>
-          <p:cNvPr id="4" name="Rounded Rectangle 3"/>
+          <p:cNvPr id="3" name="Rounded Rectangle 2"/>
           <p:cNvSpPr/>
           <p:nvPr/>
         </p:nvSpPr>
@@ -5995,7 +5680,7 @@
       </p:sp>
       <p:sp>
         <p:nvSpPr>
-          <p:cNvPr id="5" name="Rounded Rectangle 4"/>
+          <p:cNvPr id="4" name="Rounded Rectangle 3"/>
           <p:cNvSpPr/>
           <p:nvPr/>
         </p:nvSpPr>
@@ -6073,7 +5758,7 @@
       </p:sp>
       <p:sp>
         <p:nvSpPr>
-          <p:cNvPr id="6" name="Rounded Rectangle 5"/>
+          <p:cNvPr id="5" name="Rounded Rectangle 4"/>
           <p:cNvSpPr/>
           <p:nvPr/>
         </p:nvSpPr>
@@ -6151,7 +5836,7 @@
       </p:sp>
       <p:sp>
         <p:nvSpPr>
-          <p:cNvPr id="7" name="Rounded Rectangle 6"/>
+          <p:cNvPr id="6" name="Rounded Rectangle 5"/>
           <p:cNvSpPr/>
           <p:nvPr/>
         </p:nvSpPr>
@@ -6229,7 +5914,7 @@
       </p:sp>
       <p:sp>
         <p:nvSpPr>
-          <p:cNvPr id="8" name="Rounded Rectangle 7"/>
+          <p:cNvPr id="7" name="Rounded Rectangle 6"/>
           <p:cNvSpPr/>
           <p:nvPr/>
         </p:nvSpPr>

</xml_diff>

<commit_message>
Replace Angular and Gemini specific brand names with generic LLM and Web SPA Workbench terminology
</commit_message>
<xml_diff>
--- a/AmanKumar_Capstone_Presentation.pptx
+++ b/AmanKumar_Capstone_Presentation.pptx
@@ -3591,7 +3591,7 @@
               </a:defRPr>
             </a:pPr>
             <a:r>
-              <a:t>• Production-Grade Human-in-the-Loop Angular 18 SPA Workbench ready for enterprise deployment.</a:t>
+              <a:t>• Production-Grade Human-in-the-Loop Web SPA Workbench ready for enterprise deployment.</a:t>
             </a:r>
           </a:p>
         </p:txBody>
@@ -4945,7 +4945,7 @@
               </a:defRPr>
             </a:pPr>
             <a:r>
-              <a:t>Human-in-the-Loop Angular 18 Workbench UI</a:t>
+              <a:t>Human-in-the-Loop Web SPA Workbench UI</a:t>
             </a:r>
           </a:p>
         </p:txBody>

</xml_diff>